<commit_message>
Add HASOS sentence provenance outputs
</commit_message>
<xml_diff>
--- a/reports/space_hasos_full_e20_report.pptx
+++ b/reports/space_hasos_full_e20_report.pptx
@@ -2,7 +2,7 @@
 <file path=ppt/presentation.xml><?xml version="1.0" encoding="utf-8"?>
 <p:presentation xmlns:a="http://schemas.openxmlformats.org/drawingml/2006/main" xmlns:r="http://schemas.openxmlformats.org/officeDocument/2006/relationships" xmlns:p="http://schemas.openxmlformats.org/presentationml/2006/main">
   <p:sldMasterIdLst>
-    <p:sldMasterId id="2147483648" r:id="rId9"/>
+    <p:sldMasterId id="2147483648" r:id="rId10"/>
   </p:sldMasterIdLst>
   <p:sldIdLst>
     <p:sldId id="256" r:id="rId1"/>
@@ -13,6 +13,7 @@
     <p:sldId id="261" r:id="rId6"/>
     <p:sldId id="262" r:id="rId7"/>
     <p:sldId id="263" r:id="rId8"/>
+    <p:sldId id="264" r:id="rId9"/>
   </p:sldIdLst>
   <p:sldSz cx="12192000" cy="6858000" type="wide"/>
   <p:notesSz cx="6858000" cy="9144000"/>
@@ -1272,7 +1273,7 @@
                   <a:srgbClr val="2563EB"/>
                 </a:solidFill>
               </a:rPr>
-              <a:t>FORMULA</a:t>
+              <a:t>TRACEABILITY</a:t>
             </a:r>
             <a:endParaRPr lang="vi-VN" sz="800"/>
           </a:p>
@@ -1308,7 +1309,7 @@
                   <a:srgbClr val="14213D"/>
                 </a:solidFill>
               </a:rPr>
-              <a:t>SemAE scoring theo aspect</a:t>
+              <a:t>Provenance cho từng câu output</a:t>
             </a:r>
             <a:endParaRPr lang="vi-VN" sz="2300"/>
           </a:p>
@@ -1343,8 +1344,80 @@
         </p:nvSpPr>
         <p:spPr>
           <a:xfrm>
-            <a:off x="731520" y="1325880"/>
-            <a:ext cx="10424160" cy="594360"/>
+            <a:off x="685800" y="1234440"/>
+            <a:ext cx="4389120" cy="1554480"/>
+          </a:xfrm>
+          <a:prstGeom prst="rect">
+            <a:avLst/>
+          </a:prstGeom>
+          <a:solidFill>
+            <a:srgbClr val="ECFDF5"/>
+          </a:solidFill>
+          <a:ln w="9525">
+            <a:solidFill>
+              <a:srgbClr val="99F6E4"/>
+            </a:solidFill>
+          </a:ln>
+        </p:spPr>
+        <p:txBody>
+          <a:bodyPr wrap="square" lIns="91440" tIns="45720" rIns="91440" bIns="45720"/>
+          <a:lstStyle/>
+          <a:p>
+            <a:r>
+              <a:rPr lang="vi-VN" sz="1250" dirty="0">
+                <a:solidFill>
+                  <a:srgbClr val="14213D"/>
+                </a:solidFill>
+              </a:rPr>
+              <a:t>Aspect summary rows: 3660</a:t>
+            </a:r>
+            <a:endParaRPr lang="vi-VN" sz="1250"/>
+          </a:p>
+          <a:p>
+            <a:r>
+              <a:rPr lang="vi-VN" sz="1250" dirty="0">
+                <a:solidFill>
+                  <a:srgbClr val="14213D"/>
+                </a:solidFill>
+              </a:rPr>
+              <a:t>Provenance rows: 3580</a:t>
+            </a:r>
+            <a:endParaRPr lang="vi-VN" sz="1250"/>
+          </a:p>
+          <a:p>
+            <a:r>
+              <a:rPr lang="vi-VN" sz="1250" dirty="0">
+                <a:solidFill>
+                  <a:srgbClr val="14213D"/>
+                </a:solidFill>
+              </a:rPr>
+              <a:t>Coverage: 0.9781</a:t>
+            </a:r>
+            <a:endParaRPr lang="vi-VN" sz="1250"/>
+          </a:p>
+          <a:p>
+            <a:r>
+              <a:rPr lang="vi-VN" sz="1250" dirty="0">
+                <a:solidFill>
+                  <a:srgbClr val="14213D"/>
+                </a:solidFill>
+              </a:rPr>
+              <a:t>File: outputs/space_hasos_full_e20_provenance.jsonl</a:t>
+            </a:r>
+            <a:endParaRPr lang="vi-VN" sz="1250"/>
+          </a:p>
+        </p:txBody>
+      </p:sp>
+      <p:sp>
+        <p:nvSpPr>
+          <p:cNvPr id="6" name="Text 6"/>
+          <p:cNvSpPr txBox="1"/>
+          <p:nvPr/>
+        </p:nvSpPr>
+        <p:spPr>
+          <a:xfrm>
+            <a:off x="5394960" y="1234440"/>
+            <a:ext cx="5715000" cy="1874519"/>
           </a:xfrm>
           <a:prstGeom prst="rect">
             <a:avLst/>
@@ -1363,126 +1436,75 @@
           <a:lstStyle/>
           <a:p>
             <a:r>
-              <a:rPr lang="vi-VN" sz="1900" dirty="0">
-                <a:b/>
-                <a:solidFill>
-                  <a:srgbClr val="14213D"/>
-                </a:solidFill>
-              </a:rPr>
-              <a:t>score(s, k) = KL(D_z(s) || P_z) - beta * KL(D_z(s) || P_k)</a:t>
-            </a:r>
-            <a:endParaRPr lang="vi-VN" sz="1900"/>
-          </a:p>
-        </p:txBody>
-      </p:sp>
-      <p:sp>
-        <p:nvSpPr>
-          <p:cNvPr id="6" name="Text 6"/>
-          <p:cNvSpPr txBox="1"/>
-          <p:nvPr/>
-        </p:nvSpPr>
-        <p:spPr>
-          <a:xfrm>
-            <a:off x="822960" y="2286000"/>
-            <a:ext cx="5212080" cy="1645920"/>
+              <a:rPr lang="vi-VN" sz="1000" dirty="0">
+                <a:solidFill>
+                  <a:srgbClr val="14213D"/>
+                </a:solidFill>
+              </a:rPr>
+              <a:t>entity=100597 | aspect=FAC_ROOM | rank=1 | review=UR116685264</a:t>
+            </a:r>
+            <a:endParaRPr lang="vi-VN" sz="1000"/>
+          </a:p>
+          <a:p>
+            <a:r>
+              <a:rPr lang="vi-VN" sz="1000" dirty="0">
+                <a:solidFill>
+                  <a:srgbClr val="14213D"/>
+                </a:solidFill>
+              </a:rPr>
+              <a:t>seed=['room'] | sentiment=pos ['clean', 'comfortable']</a:t>
+            </a:r>
+            <a:endParaRPr lang="vi-VN" sz="1000"/>
+          </a:p>
+          <a:p>
+            <a:r>
+              <a:rPr lang="vi-VN" sz="1000" dirty="0">
+                <a:solidFill>
+                  <a:srgbClr val="14213D"/>
+                </a:solidFill>
+              </a:rPr>
+              <a:t>sentence: We had a balcony, the beds were super comfortable, room was a good size and clean.</a:t>
+            </a:r>
+            <a:endParaRPr lang="vi-VN" sz="1000"/>
+          </a:p>
+        </p:txBody>
+      </p:sp>
+      <p:sp>
+        <p:nvSpPr>
+          <p:cNvPr id="7" name="Text 7"/>
+          <p:cNvSpPr txBox="1"/>
+          <p:nvPr/>
+        </p:nvSpPr>
+        <p:spPr>
+          <a:xfrm>
+            <a:off x="685800" y="3703320"/>
+            <a:ext cx="10424160" cy="914400"/>
           </a:xfrm>
           <a:prstGeom prst="rect">
             <a:avLst/>
           </a:prstGeom>
           <a:solidFill>
-            <a:srgbClr val="FFFFFF"/>
+            <a:srgbClr val="EEF6FF"/>
           </a:solidFill>
           <a:ln w="9525">
             <a:solidFill>
-              <a:srgbClr val="D8DEE9"/>
-            </a:solidFill>
-          </a:ln>
-        </p:spPr>
-        <p:txBody>
-          <a:bodyPr wrap="square" lIns="91440" tIns="45720" rIns="91440" bIns="45720"/>
-          <a:lstStyle/>
-          <a:p>
-            <a:r>
-              <a:rPr lang="vi-VN" sz="1250" dirty="0">
-                <a:solidFill>
-                  <a:srgbClr val="14213D"/>
-                </a:solidFill>
-              </a:rPr>
-              <a:t>D_z(s): phân phối cluster của câu s.</a:t>
-            </a:r>
-            <a:endParaRPr lang="vi-VN" sz="1250"/>
-          </a:p>
-          <a:p>
-            <a:r>
-              <a:rPr lang="vi-VN" sz="1250" dirty="0">
-                <a:solidFill>
-                  <a:srgbClr val="14213D"/>
-                </a:solidFill>
-              </a:rPr>
-              <a:t>P_z: background distribution.</a:t>
-            </a:r>
-            <a:endParaRPr lang="vi-VN" sz="1250"/>
-          </a:p>
-          <a:p>
-            <a:r>
-              <a:rPr lang="vi-VN" sz="1250" dirty="0">
-                <a:solidFill>
-                  <a:srgbClr val="14213D"/>
-                </a:solidFill>
-              </a:rPr>
-              <a:t>P_k: prototype distribution của aspect k.</a:t>
-            </a:r>
-            <a:endParaRPr lang="vi-VN" sz="1250"/>
-          </a:p>
-          <a:p>
-            <a:r>
-              <a:rPr lang="vi-VN" sz="1250" dirty="0">
-                <a:solidFill>
-                  <a:srgbClr val="14213D"/>
-                </a:solidFill>
-              </a:rPr>
-              <a:t>beta=0.7 theo recipe hiện tại.</a:t>
-            </a:r>
-            <a:endParaRPr lang="vi-VN" sz="1250"/>
-          </a:p>
-        </p:txBody>
-      </p:sp>
-      <p:sp>
-        <p:nvSpPr>
-          <p:cNvPr id="7" name="Text 7"/>
-          <p:cNvSpPr txBox="1"/>
-          <p:nvPr/>
-        </p:nvSpPr>
-        <p:spPr>
-          <a:xfrm>
-            <a:off x="6400800" y="2286000"/>
-            <a:ext cx="4937760" cy="1234440"/>
-          </a:xfrm>
-          <a:prstGeom prst="rect">
-            <a:avLst/>
-          </a:prstGeom>
-          <a:solidFill>
-            <a:srgbClr val="ECFDF5"/>
-          </a:solidFill>
-          <a:ln w="9525">
-            <a:solidFill>
-              <a:srgbClr val="99F6E4"/>
-            </a:solidFill>
-          </a:ln>
-        </p:spPr>
-        <p:txBody>
-          <a:bodyPr wrap="square" lIns="91440" tIns="45720" rIns="91440" bIns="45720"/>
-          <a:lstStyle/>
-          <a:p>
-            <a:r>
-              <a:rPr lang="vi-VN" sz="1250" dirty="0">
-                <a:solidFill>
-                  <a:srgbClr val="14213D"/>
-                </a:solidFill>
-              </a:rPr>
-              <a:t>Câu có score thấp hơn được ưu tiên. Output là extractive: chọn và nối câu gốc thay vì paraphrase, nên có thể trace ngược về review/entity.</a:t>
-            </a:r>
-            <a:endParaRPr lang="vi-VN" sz="1250"/>
+              <a:srgbClr val="BFDBFE"/>
+            </a:solidFill>
+          </a:ln>
+        </p:spPr>
+        <p:txBody>
+          <a:bodyPr wrap="square" lIns="91440" tIns="45720" rIns="91440" bIns="45720"/>
+          <a:lstStyle/>
+          <a:p>
+            <a:r>
+              <a:rPr lang="vi-VN" sz="1100" dirty="0">
+                <a:solidFill>
+                  <a:srgbClr val="14213D"/>
+                </a:solidFill>
+              </a:rPr>
+              <a:t>Mỗi câu summary ghi: entity/split/aspect, summary_sentence_index, rank/score/beta, source_review_id, source_sentence_index, matched_aspect_seed, sentiment_label, matched_sentiment_keywords, was_truncated. Metric mới source_fidelity_excl_truncated loại câu bị cắt khỏi exact-match denominator.</a:t>
+            </a:r>
+            <a:endParaRPr lang="vi-VN" sz="1100"/>
           </a:p>
         </p:txBody>
       </p:sp>
@@ -1548,7 +1570,7 @@
                   <a:srgbClr val="2563EB"/>
                 </a:solidFill>
               </a:rPr>
-              <a:t>OUTPUT 1</a:t>
+              <a:t>FORMULA</a:t>
             </a:r>
             <a:endParaRPr lang="vi-VN" sz="800"/>
           </a:p>
@@ -1584,7 +1606,7 @@
                   <a:srgbClr val="14213D"/>
                 </a:solidFill>
               </a:rPr>
-              <a:t>Ví dụ aspect-only output</a:t>
+              <a:t>SemAE scoring theo aspect</a:t>
             </a:r>
             <a:endParaRPr lang="vi-VN" sz="2300"/>
           </a:p>
@@ -1619,8 +1641,8 @@
         </p:nvSpPr>
         <p:spPr>
           <a:xfrm>
-            <a:off x="685800" y="1234440"/>
-            <a:ext cx="2926080" cy="822960"/>
+            <a:off x="731520" y="1325880"/>
+            <a:ext cx="10424160" cy="594360"/>
           </a:xfrm>
           <a:prstGeom prst="rect">
             <a:avLst/>
@@ -1639,27 +1661,15 @@
           <a:lstStyle/>
           <a:p>
             <a:r>
-              <a:rPr lang="vi-VN" sz="1250" dirty="0">
+              <a:rPr lang="vi-VN" sz="1900" dirty="0">
                 <a:b/>
                 <a:solidFill>
                   <a:srgbClr val="14213D"/>
                 </a:solidFill>
               </a:rPr>
-              <a:t>Entity: 100585</a:t>
-            </a:r>
-            <a:endParaRPr lang="vi-VN" sz="1250"/>
-          </a:p>
-          <a:p>
-            <a:r>
-              <a:rPr lang="vi-VN" sz="1250" dirty="0">
-                <a:b/>
-                <a:solidFill>
-                  <a:srgbClr val="14213D"/>
-                </a:solidFill>
-              </a:rPr>
-              <a:t>Aspect: AM_ENT</a:t>
-            </a:r>
-            <a:endParaRPr lang="vi-VN" sz="1250"/>
+              <a:t>score(s, k) = KL(D_z(s) || P_z) - beta * KL(D_z(s) || P_k)</a:t>
+            </a:r>
+            <a:endParaRPr lang="vi-VN" sz="1900"/>
           </a:p>
         </p:txBody>
       </p:sp>
@@ -1671,8 +1681,8 @@
         </p:nvSpPr>
         <p:spPr>
           <a:xfrm>
-            <a:off x="3794760" y="1234440"/>
-            <a:ext cx="7315200" cy="4389120"/>
+            <a:off x="822960" y="2286000"/>
+            <a:ext cx="5212080" cy="1645920"/>
           </a:xfrm>
           <a:prstGeom prst="rect">
             <a:avLst/>
@@ -1691,36 +1701,86 @@
           <a:lstStyle/>
           <a:p>
             <a:r>
-              <a:rPr lang="vi-VN" sz="1050" dirty="0">
-                <a:solidFill>
-                  <a:srgbClr val="14213D"/>
-                </a:solidFill>
-              </a:rPr>
-              <a:t>1. I filled out one of their comment cards with a minor complaint (we found the tv system cumbersome) and I actualy received an e mail from the hotel management!</a:t>
-            </a:r>
-            <a:endParaRPr lang="vi-VN" sz="1050"/>
-          </a:p>
-          <a:p>
-            <a:r>
-              <a:rPr lang="vi-VN" sz="1050" dirty="0">
-                <a:solidFill>
-                  <a:srgbClr val="14213D"/>
-                </a:solidFill>
-              </a:rPr>
-              <a:t/>
-            </a:r>
-            <a:endParaRPr lang="vi-VN" sz="1050"/>
-          </a:p>
-          <a:p>
-            <a:r>
-              <a:rPr lang="vi-VN" sz="1050" dirty="0">
-                <a:solidFill>
-                  <a:srgbClr val="14213D"/>
-                </a:solidFill>
-              </a:rPr>
-              <a:t>2. Each room is named after a Washington winery, and one of</a:t>
-            </a:r>
-            <a:endParaRPr lang="vi-VN" sz="1050"/>
+              <a:rPr lang="vi-VN" sz="1250" dirty="0">
+                <a:solidFill>
+                  <a:srgbClr val="14213D"/>
+                </a:solidFill>
+              </a:rPr>
+              <a:t>D_z(s): phân phối cluster của câu s.</a:t>
+            </a:r>
+            <a:endParaRPr lang="vi-VN" sz="1250"/>
+          </a:p>
+          <a:p>
+            <a:r>
+              <a:rPr lang="vi-VN" sz="1250" dirty="0">
+                <a:solidFill>
+                  <a:srgbClr val="14213D"/>
+                </a:solidFill>
+              </a:rPr>
+              <a:t>P_z: background distribution.</a:t>
+            </a:r>
+            <a:endParaRPr lang="vi-VN" sz="1250"/>
+          </a:p>
+          <a:p>
+            <a:r>
+              <a:rPr lang="vi-VN" sz="1250" dirty="0">
+                <a:solidFill>
+                  <a:srgbClr val="14213D"/>
+                </a:solidFill>
+              </a:rPr>
+              <a:t>P_k: prototype distribution của aspect k.</a:t>
+            </a:r>
+            <a:endParaRPr lang="vi-VN" sz="1250"/>
+          </a:p>
+          <a:p>
+            <a:r>
+              <a:rPr lang="vi-VN" sz="1250" dirty="0">
+                <a:solidFill>
+                  <a:srgbClr val="14213D"/>
+                </a:solidFill>
+              </a:rPr>
+              <a:t>beta=0.7 theo recipe hiện tại.</a:t>
+            </a:r>
+            <a:endParaRPr lang="vi-VN" sz="1250"/>
+          </a:p>
+        </p:txBody>
+      </p:sp>
+      <p:sp>
+        <p:nvSpPr>
+          <p:cNvPr id="7" name="Text 7"/>
+          <p:cNvSpPr txBox="1"/>
+          <p:nvPr/>
+        </p:nvSpPr>
+        <p:spPr>
+          <a:xfrm>
+            <a:off x="6400800" y="2286000"/>
+            <a:ext cx="4937760" cy="1234440"/>
+          </a:xfrm>
+          <a:prstGeom prst="rect">
+            <a:avLst/>
+          </a:prstGeom>
+          <a:solidFill>
+            <a:srgbClr val="ECFDF5"/>
+          </a:solidFill>
+          <a:ln w="9525">
+            <a:solidFill>
+              <a:srgbClr val="99F6E4"/>
+            </a:solidFill>
+          </a:ln>
+        </p:spPr>
+        <p:txBody>
+          <a:bodyPr wrap="square" lIns="91440" tIns="45720" rIns="91440" bIns="45720"/>
+          <a:lstStyle/>
+          <a:p>
+            <a:r>
+              <a:rPr lang="vi-VN" sz="1250" dirty="0">
+                <a:solidFill>
+                  <a:srgbClr val="14213D"/>
+                </a:solidFill>
+              </a:rPr>
+              <a:t>Câu có score thấp hơn được ưu tiên. Output là extractive: chọn và nối câu gốc thay vì paraphrase, nên có thể trace ngược về review/entity.</a:t>
+            </a:r>
+            <a:endParaRPr lang="vi-VN" sz="1250"/>
           </a:p>
         </p:txBody>
       </p:sp>
@@ -1786,7 +1846,7 @@
                   <a:srgbClr val="2563EB"/>
                 </a:solidFill>
               </a:rPr>
-              <a:t>OUTPUT 2</a:t>
+              <a:t>OUTPUT 1</a:t>
             </a:r>
             <a:endParaRPr lang="vi-VN" sz="800"/>
           </a:p>
@@ -1822,7 +1882,7 @@
                   <a:srgbClr val="14213D"/>
                 </a:solidFill>
               </a:rPr>
-              <a:t>Ví dụ aspect + sentiment split</a:t>
+              <a:t>Ví dụ aspect-only output</a:t>
             </a:r>
             <a:endParaRPr lang="vi-VN" sz="2300"/>
           </a:p>
@@ -1858,7 +1918,7 @@
         <p:spPr>
           <a:xfrm>
             <a:off x="685800" y="1234440"/>
-            <a:ext cx="10515600" cy="4572000"/>
+            <a:ext cx="2926080" cy="822960"/>
           </a:xfrm>
           <a:prstGeom prst="rect">
             <a:avLst/>
@@ -1877,12 +1937,64 @@
           <a:lstStyle/>
           <a:p>
             <a:r>
+              <a:rPr lang="vi-VN" sz="1250" dirty="0">
+                <a:b/>
+                <a:solidFill>
+                  <a:srgbClr val="14213D"/>
+                </a:solidFill>
+              </a:rPr>
+              <a:t>Entity: 100585</a:t>
+            </a:r>
+            <a:endParaRPr lang="vi-VN" sz="1250"/>
+          </a:p>
+          <a:p>
+            <a:r>
+              <a:rPr lang="vi-VN" sz="1250" dirty="0">
+                <a:b/>
+                <a:solidFill>
+                  <a:srgbClr val="14213D"/>
+                </a:solidFill>
+              </a:rPr>
+              <a:t>Aspect: AM_ENT</a:t>
+            </a:r>
+            <a:endParaRPr lang="vi-VN" sz="1250"/>
+          </a:p>
+        </p:txBody>
+      </p:sp>
+      <p:sp>
+        <p:nvSpPr>
+          <p:cNvPr id="6" name="Text 6"/>
+          <p:cNvSpPr txBox="1"/>
+          <p:nvPr/>
+        </p:nvSpPr>
+        <p:spPr>
+          <a:xfrm>
+            <a:off x="3794760" y="1234440"/>
+            <a:ext cx="7315200" cy="4389120"/>
+          </a:xfrm>
+          <a:prstGeom prst="rect">
+            <a:avLst/>
+          </a:prstGeom>
+          <a:solidFill>
+            <a:srgbClr val="FFFFFF"/>
+          </a:solidFill>
+          <a:ln w="9525">
+            <a:solidFill>
+              <a:srgbClr val="D8DEE9"/>
+            </a:solidFill>
+          </a:ln>
+        </p:spPr>
+        <p:txBody>
+          <a:bodyPr wrap="square" lIns="91440" tIns="45720" rIns="91440" bIns="45720"/>
+          <a:lstStyle/>
+          <a:p>
+            <a:r>
               <a:rPr lang="vi-VN" sz="1050" dirty="0">
                 <a:solidFill>
                   <a:srgbClr val="14213D"/>
                 </a:solidFill>
               </a:rPr>
-              <a:t>POS</a:t>
+              <a:t>1. I filled out one of their comment cards with a minor complaint (we found the tv system cumbersome) and I actualy received an e mail from the hotel management!</a:t>
             </a:r>
             <a:endParaRPr lang="vi-VN" sz="1050"/>
           </a:p>
@@ -1893,7 +2005,7 @@
                   <a:srgbClr val="14213D"/>
                 </a:solidFill>
               </a:rPr>
-              <a:t>(empty)</a:t>
+              <a:t/>
             </a:r>
             <a:endParaRPr lang="vi-VN" sz="1050"/>
           </a:p>
@@ -1904,73 +2016,7 @@
                   <a:srgbClr val="14213D"/>
                 </a:solidFill>
               </a:rPr>
-              <a:t/>
-            </a:r>
-            <a:endParaRPr lang="vi-VN" sz="1050"/>
-          </a:p>
-          <a:p>
-            <a:r>
-              <a:rPr lang="vi-VN" sz="1050" dirty="0">
-                <a:solidFill>
-                  <a:srgbClr val="14213D"/>
-                </a:solidFill>
-              </a:rPr>
-              <a:t>NEG</a:t>
-            </a:r>
-            <a:endParaRPr lang="vi-VN" sz="1050"/>
-          </a:p>
-          <a:p>
-            <a:r>
-              <a:rPr lang="vi-VN" sz="1050" dirty="0">
-                <a:solidFill>
-                  <a:srgbClr val="14213D"/>
-                </a:solidFill>
-              </a:rPr>
-              <a:t>(empty)</a:t>
-            </a:r>
-            <a:endParaRPr lang="vi-VN" sz="1050"/>
-          </a:p>
-          <a:p>
-            <a:r>
-              <a:rPr lang="vi-VN" sz="1050" dirty="0">
-                <a:solidFill>
-                  <a:srgbClr val="14213D"/>
-                </a:solidFill>
-              </a:rPr>
-              <a:t/>
-            </a:r>
-            <a:endParaRPr lang="vi-VN" sz="1050"/>
-          </a:p>
-          <a:p>
-            <a:r>
-              <a:rPr lang="vi-VN" sz="1050" dirty="0">
-                <a:solidFill>
-                  <a:srgbClr val="14213D"/>
-                </a:solidFill>
-              </a:rPr>
-              <a:t>NEU</a:t>
-            </a:r>
-            <a:endParaRPr lang="vi-VN" sz="1050"/>
-          </a:p>
-          <a:p>
-            <a:r>
-              <a:rPr lang="vi-VN" sz="1050" dirty="0">
-                <a:solidFill>
-                  <a:srgbClr val="14213D"/>
-                </a:solidFill>
-              </a:rPr>
-              <a:t>- I filled out one of their comment cards with a minor complaint (we found the tv system cumbersome) and I actualy received an e mail ...</a:t>
-            </a:r>
-            <a:endParaRPr lang="vi-VN" sz="1050"/>
-          </a:p>
-          <a:p>
-            <a:r>
-              <a:rPr lang="vi-VN" sz="1050" dirty="0">
-                <a:solidFill>
-                  <a:srgbClr val="14213D"/>
-                </a:solidFill>
-              </a:rPr>
-              <a:t>- Each room is named after a Washington winery, and one of</a:t>
+              <a:t>2. Each room is named after a Washington winery, and one of</a:t>
             </a:r>
             <a:endParaRPr lang="vi-VN" sz="1050"/>
           </a:p>
@@ -2038,7 +2084,7 @@
                   <a:srgbClr val="2563EB"/>
                 </a:solidFill>
               </a:rPr>
-              <a:t>QUALITY</a:t>
+              <a:t>OUTPUT 2</a:t>
             </a:r>
             <a:endParaRPr lang="vi-VN" sz="800"/>
           </a:p>
@@ -2074,7 +2120,7 @@
                   <a:srgbClr val="14213D"/>
                 </a:solidFill>
               </a:rPr>
-              <a:t>Metrics và health checks</a:t>
+              <a:t>Ví dụ aspect + sentiment split</a:t>
             </a:r>
             <a:endParaRPr lang="vi-VN" sz="2300"/>
           </a:p>
@@ -2109,8 +2155,8 @@
         </p:nvSpPr>
         <p:spPr>
           <a:xfrm>
-            <a:off x="777240" y="1325880"/>
-            <a:ext cx="4480560" cy="1828800"/>
+            <a:off x="685800" y="1234440"/>
+            <a:ext cx="10515600" cy="4572000"/>
           </a:xfrm>
           <a:prstGeom prst="rect">
             <a:avLst/>
@@ -2129,86 +2175,102 @@
           <a:lstStyle/>
           <a:p>
             <a:r>
-              <a:rPr lang="vi-VN" sz="1450" dirty="0">
-                <a:solidFill>
-                  <a:srgbClr val="14213D"/>
-                </a:solidFill>
-              </a:rPr>
-              <a:t>source_fidelity: 0.6094320692641413</a:t>
-            </a:r>
-            <a:endParaRPr lang="vi-VN" sz="1450"/>
-          </a:p>
-          <a:p>
-            <a:r>
-              <a:rPr lang="vi-VN" sz="1450" dirty="0">
-                <a:solidFill>
-                  <a:srgbClr val="14213D"/>
-                </a:solidFill>
-              </a:rPr>
-              <a:t>aspect_purity: 0.5516646622593705</a:t>
-            </a:r>
-            <a:endParaRPr lang="vi-VN" sz="1450"/>
-          </a:p>
-          <a:p>
-            <a:r>
-              <a:rPr lang="vi-VN" sz="1450" dirty="0">
-                <a:solidFill>
-                  <a:srgbClr val="14213D"/>
-                </a:solidFill>
-              </a:rPr>
-              <a:t>distinct_2: 0.7179243707434944</a:t>
-            </a:r>
-            <a:endParaRPr lang="vi-VN" sz="1450"/>
-          </a:p>
-          <a:p>
-            <a:r>
-              <a:rPr lang="vi-VN" sz="1450" dirty="0">
-                <a:solidFill>
-                  <a:srgbClr val="14213D"/>
-                </a:solidFill>
-              </a:rPr>
-              <a:t>self_bleu4: 0.01087499632043265</a:t>
-            </a:r>
-            <a:endParaRPr lang="vi-VN" sz="1450"/>
-          </a:p>
-        </p:txBody>
-      </p:sp>
-      <p:sp>
-        <p:nvSpPr>
-          <p:cNvPr id="6" name="Text 6"/>
-          <p:cNvSpPr txBox="1"/>
-          <p:nvPr/>
-        </p:nvSpPr>
-        <p:spPr>
-          <a:xfrm>
-            <a:off x="5577840" y="1325880"/>
-            <a:ext cx="5486400" cy="1143000"/>
-          </a:xfrm>
-          <a:prstGeom prst="rect">
-            <a:avLst/>
-          </a:prstGeom>
-          <a:solidFill>
-            <a:srgbClr val="FFFFFF"/>
-          </a:solidFill>
-          <a:ln w="9525">
-            <a:solidFill>
-              <a:srgbClr val="D8DEE9"/>
-            </a:solidFill>
-          </a:ln>
-        </p:spPr>
-        <p:txBody>
-          <a:bodyPr wrap="square" lIns="91440" tIns="45720" rIns="91440" bIns="45720"/>
-          <a:lstStyle/>
-          <a:p>
-            <a:r>
-              <a:rPr lang="vi-VN" sz="1250" dirty="0">
-                <a:solidFill>
-                  <a:srgbClr val="14213D"/>
-                </a:solidFill>
-              </a:rPr>
-              <a:t>HASOS không có gold summary nên dùng reference-free metrics: fidelity, purity, diversity, compression. BERTScore có thể chạy thêm nếu dependency/model tải được.</a:t>
-            </a:r>
-            <a:endParaRPr lang="vi-VN" sz="1250"/>
+              <a:rPr lang="vi-VN" sz="1050" dirty="0">
+                <a:solidFill>
+                  <a:srgbClr val="14213D"/>
+                </a:solidFill>
+              </a:rPr>
+              <a:t>POS</a:t>
+            </a:r>
+            <a:endParaRPr lang="vi-VN" sz="1050"/>
+          </a:p>
+          <a:p>
+            <a:r>
+              <a:rPr lang="vi-VN" sz="1050" dirty="0">
+                <a:solidFill>
+                  <a:srgbClr val="14213D"/>
+                </a:solidFill>
+              </a:rPr>
+              <a:t>(empty)</a:t>
+            </a:r>
+            <a:endParaRPr lang="vi-VN" sz="1050"/>
+          </a:p>
+          <a:p>
+            <a:r>
+              <a:rPr lang="vi-VN" sz="1050" dirty="0">
+                <a:solidFill>
+                  <a:srgbClr val="14213D"/>
+                </a:solidFill>
+              </a:rPr>
+              <a:t/>
+            </a:r>
+            <a:endParaRPr lang="vi-VN" sz="1050"/>
+          </a:p>
+          <a:p>
+            <a:r>
+              <a:rPr lang="vi-VN" sz="1050" dirty="0">
+                <a:solidFill>
+                  <a:srgbClr val="14213D"/>
+                </a:solidFill>
+              </a:rPr>
+              <a:t>NEG</a:t>
+            </a:r>
+            <a:endParaRPr lang="vi-VN" sz="1050"/>
+          </a:p>
+          <a:p>
+            <a:r>
+              <a:rPr lang="vi-VN" sz="1050" dirty="0">
+                <a:solidFill>
+                  <a:srgbClr val="14213D"/>
+                </a:solidFill>
+              </a:rPr>
+              <a:t>(empty)</a:t>
+            </a:r>
+            <a:endParaRPr lang="vi-VN" sz="1050"/>
+          </a:p>
+          <a:p>
+            <a:r>
+              <a:rPr lang="vi-VN" sz="1050" dirty="0">
+                <a:solidFill>
+                  <a:srgbClr val="14213D"/>
+                </a:solidFill>
+              </a:rPr>
+              <a:t/>
+            </a:r>
+            <a:endParaRPr lang="vi-VN" sz="1050"/>
+          </a:p>
+          <a:p>
+            <a:r>
+              <a:rPr lang="vi-VN" sz="1050" dirty="0">
+                <a:solidFill>
+                  <a:srgbClr val="14213D"/>
+                </a:solidFill>
+              </a:rPr>
+              <a:t>NEU</a:t>
+            </a:r>
+            <a:endParaRPr lang="vi-VN" sz="1050"/>
+          </a:p>
+          <a:p>
+            <a:r>
+              <a:rPr lang="vi-VN" sz="1050" dirty="0">
+                <a:solidFill>
+                  <a:srgbClr val="14213D"/>
+                </a:solidFill>
+              </a:rPr>
+              <a:t>- I filled out one of their comment cards with a minor complaint (we found the tv system cumbersome) and I actualy received an e mail ...</a:t>
+            </a:r>
+            <a:endParaRPr lang="vi-VN" sz="1050"/>
+          </a:p>
+          <a:p>
+            <a:r>
+              <a:rPr lang="vi-VN" sz="1050" dirty="0">
+                <a:solidFill>
+                  <a:srgbClr val="14213D"/>
+                </a:solidFill>
+              </a:rPr>
+              <a:t>- Each room is named after a Washington winery, and one of</a:t>
+            </a:r>
+            <a:endParaRPr lang="vi-VN" sz="1050"/>
           </a:p>
         </p:txBody>
       </p:sp>
@@ -2221,6 +2283,253 @@
 </file>
 
 <file path=ppt/slides/slide8.xml><?xml version="1.0" encoding="utf-8"?>
+<p:sld xmlns:a="http://schemas.openxmlformats.org/drawingml/2006/main" xmlns:r="http://schemas.openxmlformats.org/officeDocument/2006/relationships" xmlns:p="http://schemas.openxmlformats.org/presentationml/2006/main">
+  <p:cSld>
+    <p:bg>
+      <p:bgPr>
+        <a:solidFill>
+          <a:srgbClr val="F8FAFC"/>
+        </a:solidFill>
+      </p:bgPr>
+    </p:bg>
+    <p:spTree>
+      <p:nvGrpSpPr>
+        <p:cNvPr id="1" name=""/>
+        <p:cNvGrpSpPr/>
+        <p:nvPr/>
+      </p:nvGrpSpPr>
+      <p:grpSpPr>
+        <a:xfrm>
+          <a:off x="0" y="0"/>
+          <a:ext cx="12192000" cy="6858000"/>
+          <a:chOff x="0" y="0"/>
+          <a:chExt cx="12192000" cy="6858000"/>
+        </a:xfrm>
+      </p:grpSpPr>
+      <p:sp>
+        <p:nvSpPr>
+          <p:cNvPr id="2" name="Text 2"/>
+          <p:cNvSpPr txBox="1"/>
+          <p:nvPr/>
+        </p:nvSpPr>
+        <p:spPr>
+          <a:xfrm>
+            <a:off x="502920" y="228600"/>
+            <a:ext cx="10972800" cy="256032"/>
+          </a:xfrm>
+          <a:prstGeom prst="rect">
+            <a:avLst/>
+          </a:prstGeom>
+          <a:noFill/>
+          <a:ln>
+            <a:noFill/>
+          </a:ln>
+        </p:spPr>
+        <p:txBody>
+          <a:bodyPr wrap="square" lIns="91440" tIns="45720" rIns="91440" bIns="45720"/>
+          <a:lstStyle/>
+          <a:p>
+            <a:r>
+              <a:rPr lang="vi-VN" sz="800" dirty="0">
+                <a:b/>
+                <a:solidFill>
+                  <a:srgbClr val="2563EB"/>
+                </a:solidFill>
+              </a:rPr>
+              <a:t>QUALITY</a:t>
+            </a:r>
+            <a:endParaRPr lang="vi-VN" sz="800"/>
+          </a:p>
+        </p:txBody>
+      </p:sp>
+      <p:sp>
+        <p:nvSpPr>
+          <p:cNvPr id="3" name="Text 3"/>
+          <p:cNvSpPr txBox="1"/>
+          <p:nvPr/>
+        </p:nvSpPr>
+        <p:spPr>
+          <a:xfrm>
+            <a:off x="502920" y="512064"/>
+            <a:ext cx="10972800" cy="457200"/>
+          </a:xfrm>
+          <a:prstGeom prst="rect">
+            <a:avLst/>
+          </a:prstGeom>
+          <a:noFill/>
+          <a:ln>
+            <a:noFill/>
+          </a:ln>
+        </p:spPr>
+        <p:txBody>
+          <a:bodyPr wrap="square" lIns="91440" tIns="45720" rIns="91440" bIns="45720"/>
+          <a:lstStyle/>
+          <a:p>
+            <a:r>
+              <a:rPr lang="vi-VN" sz="2300" dirty="0">
+                <a:b/>
+                <a:solidFill>
+                  <a:srgbClr val="14213D"/>
+                </a:solidFill>
+              </a:rPr>
+              <a:t>Metrics và health checks</a:t>
+            </a:r>
+            <a:endParaRPr lang="vi-VN" sz="2300"/>
+          </a:p>
+        </p:txBody>
+      </p:sp>
+      <p:cxnSp>
+        <p:nvCxnSpPr>
+          <p:cNvPr id="4" name="Line 4"/>
+          <p:cNvCxnSpPr/>
+          <p:nvPr/>
+        </p:nvCxnSpPr>
+        <p:spPr>
+          <a:xfrm>
+            <a:off x="502920" y="1033271"/>
+            <a:ext cx="11155680" cy="0"/>
+          </a:xfrm>
+          <a:prstGeom prst="line">
+            <a:avLst/>
+          </a:prstGeom>
+          <a:ln w="12700">
+            <a:solidFill>
+              <a:srgbClr val="D8DEE9"/>
+            </a:solidFill>
+          </a:ln>
+        </p:spPr>
+      </p:cxnSp>
+      <p:sp>
+        <p:nvSpPr>
+          <p:cNvPr id="5" name="Text 5"/>
+          <p:cNvSpPr txBox="1"/>
+          <p:nvPr/>
+        </p:nvSpPr>
+        <p:spPr>
+          <a:xfrm>
+            <a:off x="777240" y="1325880"/>
+            <a:ext cx="4709160" cy="2057400"/>
+          </a:xfrm>
+          <a:prstGeom prst="rect">
+            <a:avLst/>
+          </a:prstGeom>
+          <a:solidFill>
+            <a:srgbClr val="FFFFFF"/>
+          </a:solidFill>
+          <a:ln w="9525">
+            <a:solidFill>
+              <a:srgbClr val="D8DEE9"/>
+            </a:solidFill>
+          </a:ln>
+        </p:spPr>
+        <p:txBody>
+          <a:bodyPr wrap="square" lIns="91440" tIns="45720" rIns="91440" bIns="45720"/>
+          <a:lstStyle/>
+          <a:p>
+            <a:r>
+              <a:rPr lang="vi-VN" sz="1250" dirty="0">
+                <a:solidFill>
+                  <a:srgbClr val="14213D"/>
+                </a:solidFill>
+              </a:rPr>
+              <a:t>source_fidelity: 0.6094320692641413</a:t>
+            </a:r>
+            <a:endParaRPr lang="vi-VN" sz="1250"/>
+          </a:p>
+          <a:p>
+            <a:r>
+              <a:rPr lang="vi-VN" sz="1250" dirty="0">
+                <a:solidFill>
+                  <a:srgbClr val="14213D"/>
+                </a:solidFill>
+              </a:rPr>
+              <a:t>source_fidelity_excl_truncated: 0.96920875509799</a:t>
+            </a:r>
+            <a:endParaRPr lang="vi-VN" sz="1250"/>
+          </a:p>
+          <a:p>
+            <a:r>
+              <a:rPr lang="vi-VN" sz="1250" dirty="0">
+                <a:solidFill>
+                  <a:srgbClr val="14213D"/>
+                </a:solidFill>
+              </a:rPr>
+              <a:t>aspect_purity: 0.5516646622593705</a:t>
+            </a:r>
+            <a:endParaRPr lang="vi-VN" sz="1250"/>
+          </a:p>
+          <a:p>
+            <a:r>
+              <a:rPr lang="vi-VN" sz="1250" dirty="0">
+                <a:solidFill>
+                  <a:srgbClr val="14213D"/>
+                </a:solidFill>
+              </a:rPr>
+              <a:t>distinct_2: 0.7179243707434944</a:t>
+            </a:r>
+            <a:endParaRPr lang="vi-VN" sz="1250"/>
+          </a:p>
+          <a:p>
+            <a:r>
+              <a:rPr lang="vi-VN" sz="1250" dirty="0">
+                <a:solidFill>
+                  <a:srgbClr val="14213D"/>
+                </a:solidFill>
+              </a:rPr>
+              <a:t>self_bleu4: 0.01087499632043265</a:t>
+            </a:r>
+            <a:endParaRPr lang="vi-VN" sz="1250"/>
+          </a:p>
+        </p:txBody>
+      </p:sp>
+      <p:sp>
+        <p:nvSpPr>
+          <p:cNvPr id="6" name="Text 6"/>
+          <p:cNvSpPr txBox="1"/>
+          <p:nvPr/>
+        </p:nvSpPr>
+        <p:spPr>
+          <a:xfrm>
+            <a:off x="5577840" y="1325880"/>
+            <a:ext cx="5486400" cy="1143000"/>
+          </a:xfrm>
+          <a:prstGeom prst="rect">
+            <a:avLst/>
+          </a:prstGeom>
+          <a:solidFill>
+            <a:srgbClr val="FFFFFF"/>
+          </a:solidFill>
+          <a:ln w="9525">
+            <a:solidFill>
+              <a:srgbClr val="D8DEE9"/>
+            </a:solidFill>
+          </a:ln>
+        </p:spPr>
+        <p:txBody>
+          <a:bodyPr wrap="square" lIns="91440" tIns="45720" rIns="91440" bIns="45720"/>
+          <a:lstStyle/>
+          <a:p>
+            <a:r>
+              <a:rPr lang="vi-VN" sz="1250" dirty="0">
+                <a:solidFill>
+                  <a:srgbClr val="14213D"/>
+                </a:solidFill>
+              </a:rPr>
+              <a:t>HASOS không có gold summary nên dùng reference-free metrics: fidelity, purity, diversity, compression. BERTScore có thể chạy thêm nếu dependency/model tải được.</a:t>
+            </a:r>
+            <a:endParaRPr lang="vi-VN" sz="1250"/>
+          </a:p>
+        </p:txBody>
+      </p:sp>
+    </p:spTree>
+  </p:cSld>
+  <p:clrMapOvr>
+    <a:masterClrMapping/>
+  </p:clrMapOvr>
+</p:sld>
+</file>
+
+<file path=ppt/slides/slide9.xml><?xml version="1.0" encoding="utf-8"?>
 <p:sld xmlns:a="http://schemas.openxmlformats.org/drawingml/2006/main" xmlns:r="http://schemas.openxmlformats.org/officeDocument/2006/relationships" xmlns:p="http://schemas.openxmlformats.org/presentationml/2006/main">
   <p:cSld>
     <p:bg>

</xml_diff>

<commit_message>
Add SPACE original ROUGE baseline to HASOS report
</commit_message>
<xml_diff>
--- a/reports/space_hasos_full_e20_report.pptx
+++ b/reports/space_hasos_full_e20_report.pptx
@@ -2,7 +2,7 @@
 <file path=ppt/presentation.xml><?xml version="1.0" encoding="utf-8"?>
 <p:presentation xmlns:a="http://schemas.openxmlformats.org/drawingml/2006/main" xmlns:r="http://schemas.openxmlformats.org/officeDocument/2006/relationships" xmlns:p="http://schemas.openxmlformats.org/presentationml/2006/main">
   <p:sldMasterIdLst>
-    <p:sldMasterId id="2147483648" r:id="rId10"/>
+    <p:sldMasterId id="2147483648" r:id="rId11"/>
   </p:sldMasterIdLst>
   <p:sldIdLst>
     <p:sldId id="256" r:id="rId1"/>
@@ -14,6 +14,7 @@
     <p:sldId id="262" r:id="rId7"/>
     <p:sldId id="263" r:id="rId8"/>
     <p:sldId id="264" r:id="rId9"/>
+    <p:sldId id="265" r:id="rId10"/>
   </p:sldIdLst>
   <p:sldSz cx="12192000" cy="6858000" type="wide"/>
   <p:notesSz cx="6858000" cy="9144000"/>
@@ -343,6 +344,243 @@
 </p:sld>
 </file>
 
+<file path=ppt/slides/slide10.xml><?xml version="1.0" encoding="utf-8"?>
+<p:sld xmlns:a="http://schemas.openxmlformats.org/drawingml/2006/main" xmlns:r="http://schemas.openxmlformats.org/officeDocument/2006/relationships" xmlns:p="http://schemas.openxmlformats.org/presentationml/2006/main">
+  <p:cSld>
+    <p:bg>
+      <p:bgPr>
+        <a:solidFill>
+          <a:srgbClr val="F8FAFC"/>
+        </a:solidFill>
+      </p:bgPr>
+    </p:bg>
+    <p:spTree>
+      <p:nvGrpSpPr>
+        <p:cNvPr id="1" name=""/>
+        <p:cNvGrpSpPr/>
+        <p:nvPr/>
+      </p:nvGrpSpPr>
+      <p:grpSpPr>
+        <a:xfrm>
+          <a:off x="0" y="0"/>
+          <a:ext cx="12192000" cy="6858000"/>
+          <a:chOff x="0" y="0"/>
+          <a:chExt cx="12192000" cy="6858000"/>
+        </a:xfrm>
+      </p:grpSpPr>
+      <p:sp>
+        <p:nvSpPr>
+          <p:cNvPr id="2" name="Text 2"/>
+          <p:cNvSpPr txBox="1"/>
+          <p:nvPr/>
+        </p:nvSpPr>
+        <p:spPr>
+          <a:xfrm>
+            <a:off x="502920" y="228600"/>
+            <a:ext cx="10972800" cy="256032"/>
+          </a:xfrm>
+          <a:prstGeom prst="rect">
+            <a:avLst/>
+          </a:prstGeom>
+          <a:noFill/>
+          <a:ln>
+            <a:noFill/>
+          </a:ln>
+        </p:spPr>
+        <p:txBody>
+          <a:bodyPr wrap="square" lIns="91440" tIns="45720" rIns="91440" bIns="45720"/>
+          <a:lstStyle/>
+          <a:p>
+            <a:r>
+              <a:rPr lang="vi-VN" sz="800" dirty="0">
+                <a:b/>
+                <a:solidFill>
+                  <a:srgbClr val="2563EB"/>
+                </a:solidFill>
+              </a:rPr>
+              <a:t>CAVEATS</a:t>
+            </a:r>
+            <a:endParaRPr lang="vi-VN" sz="800"/>
+          </a:p>
+        </p:txBody>
+      </p:sp>
+      <p:sp>
+        <p:nvSpPr>
+          <p:cNvPr id="3" name="Text 3"/>
+          <p:cNvSpPr txBox="1"/>
+          <p:nvPr/>
+        </p:nvSpPr>
+        <p:spPr>
+          <a:xfrm>
+            <a:off x="502920" y="512064"/>
+            <a:ext cx="10972800" cy="457200"/>
+          </a:xfrm>
+          <a:prstGeom prst="rect">
+            <a:avLst/>
+          </a:prstGeom>
+          <a:noFill/>
+          <a:ln>
+            <a:noFill/>
+          </a:ln>
+        </p:spPr>
+        <p:txBody>
+          <a:bodyPr wrap="square" lIns="91440" tIns="45720" rIns="91440" bIns="45720"/>
+          <a:lstStyle/>
+          <a:p>
+            <a:r>
+              <a:rPr lang="vi-VN" sz="2300" dirty="0">
+                <a:b/>
+                <a:solidFill>
+                  <a:srgbClr val="14213D"/>
+                </a:solidFill>
+              </a:rPr>
+              <a:t>Limitations và quyết định kỹ thuật</a:t>
+            </a:r>
+            <a:endParaRPr lang="vi-VN" sz="2300"/>
+          </a:p>
+        </p:txBody>
+      </p:sp>
+      <p:cxnSp>
+        <p:nvCxnSpPr>
+          <p:cNvPr id="4" name="Line 4"/>
+          <p:cNvCxnSpPr/>
+          <p:nvPr/>
+        </p:nvCxnSpPr>
+        <p:spPr>
+          <a:xfrm>
+            <a:off x="502920" y="1033271"/>
+            <a:ext cx="11155680" cy="0"/>
+          </a:xfrm>
+          <a:prstGeom prst="line">
+            <a:avLst/>
+          </a:prstGeom>
+          <a:ln w="12700">
+            <a:solidFill>
+              <a:srgbClr val="D8DEE9"/>
+            </a:solidFill>
+          </a:ln>
+        </p:spPr>
+      </p:cxnSp>
+      <p:sp>
+        <p:nvSpPr>
+          <p:cNvPr id="5" name="Text 5"/>
+          <p:cNvSpPr txBox="1"/>
+          <p:nvPr/>
+        </p:nvSpPr>
+        <p:spPr>
+          <a:xfrm>
+            <a:off x="777240" y="1325880"/>
+            <a:ext cx="10332720" cy="2194560"/>
+          </a:xfrm>
+          <a:prstGeom prst="rect">
+            <a:avLst/>
+          </a:prstGeom>
+          <a:solidFill>
+            <a:srgbClr val="FFFFFF"/>
+          </a:solidFill>
+          <a:ln w="9525">
+            <a:solidFill>
+              <a:srgbClr val="D8DEE9"/>
+            </a:solidFill>
+          </a:ln>
+        </p:spPr>
+        <p:txBody>
+          <a:bodyPr wrap="square" lIns="91440" tIns="45720" rIns="91440" bIns="45720"/>
+          <a:lstStyle/>
+          <a:p>
+            <a:r>
+              <a:rPr lang="vi-VN" sz="1250" dirty="0">
+                <a:solidFill>
+                  <a:srgbClr val="14213D"/>
+                </a:solidFill>
+              </a:rPr>
+              <a:t>1. Sentiment là keyword post-processing, không phải sentiment-aware ranking.</a:t>
+            </a:r>
+            <a:endParaRPr lang="vi-VN" sz="1250"/>
+          </a:p>
+          <a:p>
+            <a:r>
+              <a:rPr lang="vi-VN" sz="1250" dirty="0">
+                <a:solidFill>
+                  <a:srgbClr val="14213D"/>
+                </a:solidFill>
+              </a:rPr>
+              <a:t>2. Output extractive nên traceable nhưng có thể dài hoặc multi-aspect.</a:t>
+            </a:r>
+            <a:endParaRPr lang="vi-VN" sz="1250"/>
+          </a:p>
+          <a:p>
+            <a:r>
+              <a:rPr lang="vi-VN" sz="1250" dirty="0">
+                <a:solidFill>
+                  <a:srgbClr val="14213D"/>
+                </a:solidFill>
+              </a:rPr>
+              <a:t>3. Tokenizer là artifact bắt buộc và phải sync cùng checkpoint.</a:t>
+            </a:r>
+            <a:endParaRPr lang="vi-VN" sz="1250"/>
+          </a:p>
+          <a:p>
+            <a:r>
+              <a:rPr lang="vi-VN" sz="1250" dirty="0">
+                <a:solidFill>
+                  <a:srgbClr val="14213D"/>
+                </a:solidFill>
+              </a:rPr>
+              <a:t>4. Run này ưu tiên có output đúng pipeline trước deadline; xem trace/log để đánh giá độ sạch numerical.</a:t>
+            </a:r>
+            <a:endParaRPr lang="vi-VN" sz="1250"/>
+          </a:p>
+        </p:txBody>
+      </p:sp>
+      <p:sp>
+        <p:nvSpPr>
+          <p:cNvPr id="6" name="Text 6"/>
+          <p:cNvSpPr txBox="1"/>
+          <p:nvPr/>
+        </p:nvSpPr>
+        <p:spPr>
+          <a:xfrm>
+            <a:off x="777240" y="4160520"/>
+            <a:ext cx="10332720" cy="594360"/>
+          </a:xfrm>
+          <a:prstGeom prst="rect">
+            <a:avLst/>
+          </a:prstGeom>
+          <a:solidFill>
+            <a:srgbClr val="ECFDF5"/>
+          </a:solidFill>
+          <a:ln w="9525">
+            <a:solidFill>
+              <a:srgbClr val="99F6E4"/>
+            </a:solidFill>
+          </a:ln>
+        </p:spPr>
+        <p:txBody>
+          <a:bodyPr wrap="square" lIns="91440" tIns="45720" rIns="91440" bIns="45720"/>
+          <a:lstStyle/>
+          <a:p>
+            <a:r>
+              <a:rPr lang="vi-VN" sz="1300" dirty="0">
+                <a:b/>
+                <a:solidFill>
+                  <a:srgbClr val="14213D"/>
+                </a:solidFill>
+              </a:rPr>
+              <a:t>Final deck path: outputs/space_hasos_full_e20_pipeline_report.pptx</a:t>
+            </a:r>
+            <a:endParaRPr lang="vi-VN" sz="1300"/>
+          </a:p>
+        </p:txBody>
+      </p:sp>
+    </p:spTree>
+  </p:cSld>
+  <p:clrMapOvr>
+    <a:masterClrMapping/>
+  </p:clrMapOvr>
+</p:sld>
+</file>
+
 <file path=ppt/slides/slide2.xml><?xml version="1.0" encoding="utf-8"?>
 <p:sld xmlns:a="http://schemas.openxmlformats.org/drawingml/2006/main" xmlns:r="http://schemas.openxmlformats.org/officeDocument/2006/relationships" xmlns:p="http://schemas.openxmlformats.org/presentationml/2006/main">
   <p:cSld>
@@ -1369,7 +1607,7 @@
                   <a:srgbClr val="14213D"/>
                 </a:solidFill>
               </a:rPr>
-              <a:t>Aspect summary rows: 3660</a:t>
+              <a:t>Aspect summary rows: 3580</a:t>
             </a:r>
             <a:endParaRPr lang="vi-VN" sz="1250"/>
           </a:p>
@@ -1391,7 +1629,7 @@
                   <a:srgbClr val="14213D"/>
                 </a:solidFill>
               </a:rPr>
-              <a:t>Coverage: 0.9781</a:t>
+              <a:t>Coverage: 1.0000</a:t>
             </a:r>
             <a:endParaRPr lang="vi-VN" sz="1250"/>
           </a:p>
@@ -1846,7 +2084,7 @@
                   <a:srgbClr val="2563EB"/>
                 </a:solidFill>
               </a:rPr>
-              <a:t>OUTPUT 1</a:t>
+              <a:t>OLD BASELINE</a:t>
             </a:r>
             <a:endParaRPr lang="vi-VN" sz="800"/>
           </a:p>
@@ -1882,7 +2120,7 @@
                   <a:srgbClr val="14213D"/>
                 </a:solidFill>
               </a:rPr>
-              <a:t>Ví dụ aspect-only output</a:t>
+              <a:t>SPACE original aspects: official ROUGE</a:t>
             </a:r>
             <a:endParaRPr lang="vi-VN" sz="2300"/>
           </a:p>
@@ -1918,7 +2156,46 @@
         <p:spPr>
           <a:xfrm>
             <a:off x="685800" y="1234440"/>
-            <a:ext cx="2926080" cy="822960"/>
+            <a:ext cx="10378440" cy="868680"/>
+          </a:xfrm>
+          <a:prstGeom prst="rect">
+            <a:avLst/>
+          </a:prstGeom>
+          <a:solidFill>
+            <a:srgbClr val="FFF7ED"/>
+          </a:solidFill>
+          <a:ln w="9525">
+            <a:solidFill>
+              <a:srgbClr val="FDBA74"/>
+            </a:solidFill>
+          </a:ln>
+        </p:spPr>
+        <p:txBody>
+          <a:bodyPr wrap="square" lIns="91440" tIns="45720" rIns="91440" bIns="45720"/>
+          <a:lstStyle/>
+          <a:p>
+            <a:r>
+              <a:rPr lang="vi-VN" sz="1120" dirty="0">
+                <a:solidFill>
+                  <a:srgbClr val="14213D"/>
+                </a:solidFill>
+              </a:rPr>
+              <a:t>Bản cũ dùng đúng SPACE benchmark và 6 aspect gốc: building, cleanliness, food, location, rooms, service. Run này chạy without --no_eval nên điểm dưới đây là pyrouge official, khác với HASOS reference-free metrics.</a:t>
+            </a:r>
+            <a:endParaRPr lang="vi-VN" sz="1120"/>
+          </a:p>
+        </p:txBody>
+      </p:sp>
+      <p:sp>
+        <p:nvSpPr>
+          <p:cNvPr id="6" name="Text 6"/>
+          <p:cNvSpPr txBox="1"/>
+          <p:nvPr/>
+        </p:nvSpPr>
+        <p:spPr>
+          <a:xfrm>
+            <a:off x="777240" y="2423160"/>
+            <a:ext cx="4526280" cy="1508760"/>
           </a:xfrm>
           <a:prstGeom prst="rect">
             <a:avLst/>
@@ -1938,49 +2215,185 @@
           <a:p>
             <a:r>
               <a:rPr lang="vi-VN" sz="1250" dirty="0">
-                <a:b/>
-                <a:solidFill>
-                  <a:srgbClr val="14213D"/>
-                </a:solidFill>
-              </a:rPr>
-              <a:t>Entity: 100585</a:t>
+                <a:solidFill>
+                  <a:srgbClr val="14213D"/>
+                </a:solidFill>
+              </a:rPr>
+              <a:t>Macro F1 by split</a:t>
             </a:r>
             <a:endParaRPr lang="vi-VN" sz="1250"/>
           </a:p>
           <a:p>
             <a:r>
               <a:rPr lang="vi-VN" sz="1250" dirty="0">
-                <a:b/>
-                <a:solidFill>
-                  <a:srgbClr val="14213D"/>
-                </a:solidFill>
-              </a:rPr>
-              <a:t>Aspect: AM_ENT</a:t>
+                <a:solidFill>
+                  <a:srgbClr val="14213D"/>
+                </a:solidFill>
+              </a:rPr>
+              <a:t>DEV   R1=0.3068  R2=0.0827  RL=0.2195</a:t>
             </a:r>
             <a:endParaRPr lang="vi-VN" sz="1250"/>
           </a:p>
-        </p:txBody>
-      </p:sp>
-      <p:sp>
-        <p:nvSpPr>
-          <p:cNvPr id="6" name="Text 6"/>
-          <p:cNvSpPr txBox="1"/>
-          <p:nvPr/>
-        </p:nvSpPr>
-        <p:spPr>
-          <a:xfrm>
-            <a:off x="3794760" y="1234440"/>
-            <a:ext cx="7315200" cy="4389120"/>
+          <a:p>
+            <a:r>
+              <a:rPr lang="vi-VN" sz="1250" dirty="0">
+                <a:solidFill>
+                  <a:srgbClr val="14213D"/>
+                </a:solidFill>
+              </a:rPr>
+              <a:t>TEST  R1=0.3002  R2=0.0879  RL=0.2179</a:t>
+            </a:r>
+            <a:endParaRPr lang="vi-VN" sz="1250"/>
+          </a:p>
+          <a:p>
+            <a:r>
+              <a:rPr lang="vi-VN" sz="1250" dirty="0">
+                <a:solidFill>
+                  <a:srgbClr val="14213D"/>
+                </a:solidFill>
+              </a:rPr>
+              <a:t>ALL   R1=0.3033  R2=0.0857  RL=0.2188</a:t>
+            </a:r>
+            <a:endParaRPr lang="vi-VN" sz="1250"/>
+          </a:p>
+        </p:txBody>
+      </p:sp>
+      <p:sp>
+        <p:nvSpPr>
+          <p:cNvPr id="7" name="Text 7"/>
+          <p:cNvSpPr txBox="1"/>
+          <p:nvPr/>
+        </p:nvSpPr>
+        <p:spPr>
+          <a:xfrm>
+            <a:off x="5623560" y="2240280"/>
+            <a:ext cx="5440680" cy="2423160"/>
           </a:xfrm>
           <a:prstGeom prst="rect">
             <a:avLst/>
           </a:prstGeom>
           <a:solidFill>
-            <a:srgbClr val="FFFFFF"/>
+            <a:srgbClr val="ECFDF5"/>
           </a:solidFill>
           <a:ln w="9525">
             <a:solidFill>
-              <a:srgbClr val="D8DEE9"/>
+              <a:srgbClr val="99F6E4"/>
+            </a:solidFill>
+          </a:ln>
+        </p:spPr>
+        <p:txBody>
+          <a:bodyPr wrap="square" lIns="91440" tIns="45720" rIns="91440" bIns="45720"/>
+          <a:lstStyle/>
+          <a:p>
+            <a:r>
+              <a:rPr lang="vi-VN" sz="850" dirty="0">
+                <a:solidFill>
+                  <a:srgbClr val="14213D"/>
+                </a:solidFill>
+              </a:rPr>
+              <a:t>ALL split by aspect</a:t>
+            </a:r>
+            <a:endParaRPr lang="vi-VN" sz="850"/>
+          </a:p>
+          <a:p>
+            <a:r>
+              <a:rPr lang="vi-VN" sz="850" dirty="0">
+                <a:solidFill>
+                  <a:srgbClr val="14213D"/>
+                </a:solidFill>
+              </a:rPr>
+              <a:t>R1 / R2 / RL</a:t>
+            </a:r>
+            <a:endParaRPr lang="vi-VN" sz="850"/>
+          </a:p>
+          <a:p>
+            <a:r>
+              <a:rPr lang="vi-VN" sz="850" dirty="0">
+                <a:solidFill>
+                  <a:srgbClr val="14213D"/>
+                </a:solidFill>
+              </a:rPr>
+              <a:t>building     0.2656 / 0.0591 / 0.1939</a:t>
+            </a:r>
+            <a:endParaRPr lang="vi-VN" sz="850"/>
+          </a:p>
+          <a:p>
+            <a:r>
+              <a:rPr lang="vi-VN" sz="850" dirty="0">
+                <a:solidFill>
+                  <a:srgbClr val="14213D"/>
+                </a:solidFill>
+              </a:rPr>
+              <a:t>cleanliness  0.2653 / 0.0803 / 0.2159</a:t>
+            </a:r>
+            <a:endParaRPr lang="vi-VN" sz="850"/>
+          </a:p>
+          <a:p>
+            <a:r>
+              <a:rPr lang="vi-VN" sz="850" dirty="0">
+                <a:solidFill>
+                  <a:srgbClr val="14213D"/>
+                </a:solidFill>
+              </a:rPr>
+              <a:t>food         0.3090 / 0.0917 / 0.2183</a:t>
+            </a:r>
+            <a:endParaRPr lang="vi-VN" sz="850"/>
+          </a:p>
+          <a:p>
+            <a:r>
+              <a:rPr lang="vi-VN" sz="850" dirty="0">
+                <a:solidFill>
+                  <a:srgbClr val="14213D"/>
+                </a:solidFill>
+              </a:rPr>
+              <a:t>location     0.3413 / 0.1072 / 0.2334</a:t>
+            </a:r>
+            <a:endParaRPr lang="vi-VN" sz="850"/>
+          </a:p>
+          <a:p>
+            <a:r>
+              <a:rPr lang="vi-VN" sz="850" dirty="0">
+                <a:solidFill>
+                  <a:srgbClr val="14213D"/>
+                </a:solidFill>
+              </a:rPr>
+              <a:t>rooms        0.3441 / 0.0869 / 0.2345</a:t>
+            </a:r>
+            <a:endParaRPr lang="vi-VN" sz="850"/>
+          </a:p>
+          <a:p>
+            <a:r>
+              <a:rPr lang="vi-VN" sz="850" dirty="0">
+                <a:solidFill>
+                  <a:srgbClr val="14213D"/>
+                </a:solidFill>
+              </a:rPr>
+              <a:t>service      0.2943 / 0.0888 / 0.2171</a:t>
+            </a:r>
+            <a:endParaRPr lang="vi-VN" sz="850"/>
+          </a:p>
+        </p:txBody>
+      </p:sp>
+      <p:sp>
+        <p:nvSpPr>
+          <p:cNvPr id="8" name="Text 8"/>
+          <p:cNvSpPr txBox="1"/>
+          <p:nvPr/>
+        </p:nvSpPr>
+        <p:spPr>
+          <a:xfrm>
+            <a:off x="777240" y="4892040"/>
+            <a:ext cx="10195560" cy="502920"/>
+          </a:xfrm>
+          <a:prstGeom prst="rect">
+            <a:avLst/>
+          </a:prstGeom>
+          <a:solidFill>
+            <a:srgbClr val="EEF6FF"/>
+          </a:solidFill>
+          <a:ln w="9525">
+            <a:solidFill>
+              <a:srgbClr val="BFDBFE"/>
             </a:solidFill>
           </a:ln>
         </p:spPr>
@@ -1994,29 +2407,7 @@
                   <a:srgbClr val="14213D"/>
                 </a:solidFill>
               </a:rPr>
-              <a:t>1. I filled out one of their comment cards with a minor complaint (we found the tv system cumbersome) and I actualy received an e mail from the hotel management!</a:t>
-            </a:r>
-            <a:endParaRPr lang="vi-VN" sz="1050"/>
-          </a:p>
-          <a:p>
-            <a:r>
-              <a:rPr lang="vi-VN" sz="1050" dirty="0">
-                <a:solidFill>
-                  <a:srgbClr val="14213D"/>
-                </a:solidFill>
-              </a:rPr>
-              <a:t/>
-            </a:r>
-            <a:endParaRPr lang="vi-VN" sz="1050"/>
-          </a:p>
-          <a:p>
-            <a:r>
-              <a:rPr lang="vi-VN" sz="1050" dirty="0">
-                <a:solidFill>
-                  <a:srgbClr val="14213D"/>
-                </a:solidFill>
-              </a:rPr>
-              <a:t>2. Each room is named after a Washington winery, and one of</a:t>
+              <a:t>Kết luận so sánh: HASOS 29 aspects là adaptation/inference mới không có gold summary; SPACE original 6 aspects là baseline có gold và có thể so sánh bằng ROUGE.</a:t>
             </a:r>
             <a:endParaRPr lang="vi-VN" sz="1050"/>
           </a:p>
@@ -2084,7 +2475,7 @@
                   <a:srgbClr val="2563EB"/>
                 </a:solidFill>
               </a:rPr>
-              <a:t>OUTPUT 2</a:t>
+              <a:t>OUTPUT 1</a:t>
             </a:r>
             <a:endParaRPr lang="vi-VN" sz="800"/>
           </a:p>
@@ -2120,7 +2511,7 @@
                   <a:srgbClr val="14213D"/>
                 </a:solidFill>
               </a:rPr>
-              <a:t>Ví dụ aspect + sentiment split</a:t>
+              <a:t>Ví dụ aspect-only output</a:t>
             </a:r>
             <a:endParaRPr lang="vi-VN" sz="2300"/>
           </a:p>
@@ -2156,7 +2547,7 @@
         <p:spPr>
           <a:xfrm>
             <a:off x="685800" y="1234440"/>
-            <a:ext cx="10515600" cy="4572000"/>
+            <a:ext cx="2926080" cy="822960"/>
           </a:xfrm>
           <a:prstGeom prst="rect">
             <a:avLst/>
@@ -2175,12 +2566,64 @@
           <a:lstStyle/>
           <a:p>
             <a:r>
+              <a:rPr lang="vi-VN" sz="1250" dirty="0">
+                <a:b/>
+                <a:solidFill>
+                  <a:srgbClr val="14213D"/>
+                </a:solidFill>
+              </a:rPr>
+              <a:t>Entity: 100585</a:t>
+            </a:r>
+            <a:endParaRPr lang="vi-VN" sz="1250"/>
+          </a:p>
+          <a:p>
+            <a:r>
+              <a:rPr lang="vi-VN" sz="1250" dirty="0">
+                <a:b/>
+                <a:solidFill>
+                  <a:srgbClr val="14213D"/>
+                </a:solidFill>
+              </a:rPr>
+              <a:t>Aspect: AM_ENT</a:t>
+            </a:r>
+            <a:endParaRPr lang="vi-VN" sz="1250"/>
+          </a:p>
+        </p:txBody>
+      </p:sp>
+      <p:sp>
+        <p:nvSpPr>
+          <p:cNvPr id="6" name="Text 6"/>
+          <p:cNvSpPr txBox="1"/>
+          <p:nvPr/>
+        </p:nvSpPr>
+        <p:spPr>
+          <a:xfrm>
+            <a:off x="3794760" y="1234440"/>
+            <a:ext cx="7315200" cy="4389120"/>
+          </a:xfrm>
+          <a:prstGeom prst="rect">
+            <a:avLst/>
+          </a:prstGeom>
+          <a:solidFill>
+            <a:srgbClr val="FFFFFF"/>
+          </a:solidFill>
+          <a:ln w="9525">
+            <a:solidFill>
+              <a:srgbClr val="D8DEE9"/>
+            </a:solidFill>
+          </a:ln>
+        </p:spPr>
+        <p:txBody>
+          <a:bodyPr wrap="square" lIns="91440" tIns="45720" rIns="91440" bIns="45720"/>
+          <a:lstStyle/>
+          <a:p>
+            <a:r>
               <a:rPr lang="vi-VN" sz="1050" dirty="0">
                 <a:solidFill>
                   <a:srgbClr val="14213D"/>
                 </a:solidFill>
               </a:rPr>
-              <a:t>POS</a:t>
+              <a:t>1. I filled out one of their comment cards with a minor complaint (we found the tv system cumbersome) and I actualy received an e mail from the hotel management!</a:t>
             </a:r>
             <a:endParaRPr lang="vi-VN" sz="1050"/>
           </a:p>
@@ -2191,7 +2634,7 @@
                   <a:srgbClr val="14213D"/>
                 </a:solidFill>
               </a:rPr>
-              <a:t>(empty)</a:t>
+              <a:t/>
             </a:r>
             <a:endParaRPr lang="vi-VN" sz="1050"/>
           </a:p>
@@ -2202,73 +2645,7 @@
                   <a:srgbClr val="14213D"/>
                 </a:solidFill>
               </a:rPr>
-              <a:t/>
-            </a:r>
-            <a:endParaRPr lang="vi-VN" sz="1050"/>
-          </a:p>
-          <a:p>
-            <a:r>
-              <a:rPr lang="vi-VN" sz="1050" dirty="0">
-                <a:solidFill>
-                  <a:srgbClr val="14213D"/>
-                </a:solidFill>
-              </a:rPr>
-              <a:t>NEG</a:t>
-            </a:r>
-            <a:endParaRPr lang="vi-VN" sz="1050"/>
-          </a:p>
-          <a:p>
-            <a:r>
-              <a:rPr lang="vi-VN" sz="1050" dirty="0">
-                <a:solidFill>
-                  <a:srgbClr val="14213D"/>
-                </a:solidFill>
-              </a:rPr>
-              <a:t>(empty)</a:t>
-            </a:r>
-            <a:endParaRPr lang="vi-VN" sz="1050"/>
-          </a:p>
-          <a:p>
-            <a:r>
-              <a:rPr lang="vi-VN" sz="1050" dirty="0">
-                <a:solidFill>
-                  <a:srgbClr val="14213D"/>
-                </a:solidFill>
-              </a:rPr>
-              <a:t/>
-            </a:r>
-            <a:endParaRPr lang="vi-VN" sz="1050"/>
-          </a:p>
-          <a:p>
-            <a:r>
-              <a:rPr lang="vi-VN" sz="1050" dirty="0">
-                <a:solidFill>
-                  <a:srgbClr val="14213D"/>
-                </a:solidFill>
-              </a:rPr>
-              <a:t>NEU</a:t>
-            </a:r>
-            <a:endParaRPr lang="vi-VN" sz="1050"/>
-          </a:p>
-          <a:p>
-            <a:r>
-              <a:rPr lang="vi-VN" sz="1050" dirty="0">
-                <a:solidFill>
-                  <a:srgbClr val="14213D"/>
-                </a:solidFill>
-              </a:rPr>
-              <a:t>- I filled out one of their comment cards with a minor complaint (we found the tv system cumbersome) and I actualy received an e mail ...</a:t>
-            </a:r>
-            <a:endParaRPr lang="vi-VN" sz="1050"/>
-          </a:p>
-          <a:p>
-            <a:r>
-              <a:rPr lang="vi-VN" sz="1050" dirty="0">
-                <a:solidFill>
-                  <a:srgbClr val="14213D"/>
-                </a:solidFill>
-              </a:rPr>
-              <a:t>- Each room is named after a Washington winery, and one of</a:t>
+              <a:t>2. Each room is named after a Washington winery, and one of</a:t>
             </a:r>
             <a:endParaRPr lang="vi-VN" sz="1050"/>
           </a:p>
@@ -2336,7 +2713,7 @@
                   <a:srgbClr val="2563EB"/>
                 </a:solidFill>
               </a:rPr>
-              <a:t>QUALITY</a:t>
+              <a:t>OUTPUT 2</a:t>
             </a:r>
             <a:endParaRPr lang="vi-VN" sz="800"/>
           </a:p>
@@ -2372,7 +2749,7 @@
                   <a:srgbClr val="14213D"/>
                 </a:solidFill>
               </a:rPr>
-              <a:t>Metrics và health checks</a:t>
+              <a:t>Ví dụ aspect + sentiment split</a:t>
             </a:r>
             <a:endParaRPr lang="vi-VN" sz="2300"/>
           </a:p>
@@ -2407,8 +2784,8 @@
         </p:nvSpPr>
         <p:spPr>
           <a:xfrm>
-            <a:off x="777240" y="1325880"/>
-            <a:ext cx="4709160" cy="2057400"/>
+            <a:off x="685800" y="1234440"/>
+            <a:ext cx="10515600" cy="4572000"/>
           </a:xfrm>
           <a:prstGeom prst="rect">
             <a:avLst/>
@@ -2427,97 +2804,102 @@
           <a:lstStyle/>
           <a:p>
             <a:r>
-              <a:rPr lang="vi-VN" sz="1250" dirty="0">
-                <a:solidFill>
-                  <a:srgbClr val="14213D"/>
-                </a:solidFill>
-              </a:rPr>
-              <a:t>source_fidelity: 0.6094320692641413</a:t>
-            </a:r>
-            <a:endParaRPr lang="vi-VN" sz="1250"/>
-          </a:p>
-          <a:p>
-            <a:r>
-              <a:rPr lang="vi-VN" sz="1250" dirty="0">
-                <a:solidFill>
-                  <a:srgbClr val="14213D"/>
-                </a:solidFill>
-              </a:rPr>
-              <a:t>source_fidelity_excl_truncated: 0.96920875509799</a:t>
-            </a:r>
-            <a:endParaRPr lang="vi-VN" sz="1250"/>
-          </a:p>
-          <a:p>
-            <a:r>
-              <a:rPr lang="vi-VN" sz="1250" dirty="0">
-                <a:solidFill>
-                  <a:srgbClr val="14213D"/>
-                </a:solidFill>
-              </a:rPr>
-              <a:t>aspect_purity: 0.5516646622593705</a:t>
-            </a:r>
-            <a:endParaRPr lang="vi-VN" sz="1250"/>
-          </a:p>
-          <a:p>
-            <a:r>
-              <a:rPr lang="vi-VN" sz="1250" dirty="0">
-                <a:solidFill>
-                  <a:srgbClr val="14213D"/>
-                </a:solidFill>
-              </a:rPr>
-              <a:t>distinct_2: 0.7179243707434944</a:t>
-            </a:r>
-            <a:endParaRPr lang="vi-VN" sz="1250"/>
-          </a:p>
-          <a:p>
-            <a:r>
-              <a:rPr lang="vi-VN" sz="1250" dirty="0">
-                <a:solidFill>
-                  <a:srgbClr val="14213D"/>
-                </a:solidFill>
-              </a:rPr>
-              <a:t>self_bleu4: 0.01087499632043265</a:t>
-            </a:r>
-            <a:endParaRPr lang="vi-VN" sz="1250"/>
-          </a:p>
-        </p:txBody>
-      </p:sp>
-      <p:sp>
-        <p:nvSpPr>
-          <p:cNvPr id="6" name="Text 6"/>
-          <p:cNvSpPr txBox="1"/>
-          <p:nvPr/>
-        </p:nvSpPr>
-        <p:spPr>
-          <a:xfrm>
-            <a:off x="5577840" y="1325880"/>
-            <a:ext cx="5486400" cy="1143000"/>
-          </a:xfrm>
-          <a:prstGeom prst="rect">
-            <a:avLst/>
-          </a:prstGeom>
-          <a:solidFill>
-            <a:srgbClr val="FFFFFF"/>
-          </a:solidFill>
-          <a:ln w="9525">
-            <a:solidFill>
-              <a:srgbClr val="D8DEE9"/>
-            </a:solidFill>
-          </a:ln>
-        </p:spPr>
-        <p:txBody>
-          <a:bodyPr wrap="square" lIns="91440" tIns="45720" rIns="91440" bIns="45720"/>
-          <a:lstStyle/>
-          <a:p>
-            <a:r>
-              <a:rPr lang="vi-VN" sz="1250" dirty="0">
-                <a:solidFill>
-                  <a:srgbClr val="14213D"/>
-                </a:solidFill>
-              </a:rPr>
-              <a:t>HASOS không có gold summary nên dùng reference-free metrics: fidelity, purity, diversity, compression. BERTScore có thể chạy thêm nếu dependency/model tải được.</a:t>
-            </a:r>
-            <a:endParaRPr lang="vi-VN" sz="1250"/>
+              <a:rPr lang="vi-VN" sz="1050" dirty="0">
+                <a:solidFill>
+                  <a:srgbClr val="14213D"/>
+                </a:solidFill>
+              </a:rPr>
+              <a:t>POS</a:t>
+            </a:r>
+            <a:endParaRPr lang="vi-VN" sz="1050"/>
+          </a:p>
+          <a:p>
+            <a:r>
+              <a:rPr lang="vi-VN" sz="1050" dirty="0">
+                <a:solidFill>
+                  <a:srgbClr val="14213D"/>
+                </a:solidFill>
+              </a:rPr>
+              <a:t>(empty)</a:t>
+            </a:r>
+            <a:endParaRPr lang="vi-VN" sz="1050"/>
+          </a:p>
+          <a:p>
+            <a:r>
+              <a:rPr lang="vi-VN" sz="1050" dirty="0">
+                <a:solidFill>
+                  <a:srgbClr val="14213D"/>
+                </a:solidFill>
+              </a:rPr>
+              <a:t/>
+            </a:r>
+            <a:endParaRPr lang="vi-VN" sz="1050"/>
+          </a:p>
+          <a:p>
+            <a:r>
+              <a:rPr lang="vi-VN" sz="1050" dirty="0">
+                <a:solidFill>
+                  <a:srgbClr val="14213D"/>
+                </a:solidFill>
+              </a:rPr>
+              <a:t>NEG</a:t>
+            </a:r>
+            <a:endParaRPr lang="vi-VN" sz="1050"/>
+          </a:p>
+          <a:p>
+            <a:r>
+              <a:rPr lang="vi-VN" sz="1050" dirty="0">
+                <a:solidFill>
+                  <a:srgbClr val="14213D"/>
+                </a:solidFill>
+              </a:rPr>
+              <a:t>(empty)</a:t>
+            </a:r>
+            <a:endParaRPr lang="vi-VN" sz="1050"/>
+          </a:p>
+          <a:p>
+            <a:r>
+              <a:rPr lang="vi-VN" sz="1050" dirty="0">
+                <a:solidFill>
+                  <a:srgbClr val="14213D"/>
+                </a:solidFill>
+              </a:rPr>
+              <a:t/>
+            </a:r>
+            <a:endParaRPr lang="vi-VN" sz="1050"/>
+          </a:p>
+          <a:p>
+            <a:r>
+              <a:rPr lang="vi-VN" sz="1050" dirty="0">
+                <a:solidFill>
+                  <a:srgbClr val="14213D"/>
+                </a:solidFill>
+              </a:rPr>
+              <a:t>NEU</a:t>
+            </a:r>
+            <a:endParaRPr lang="vi-VN" sz="1050"/>
+          </a:p>
+          <a:p>
+            <a:r>
+              <a:rPr lang="vi-VN" sz="1050" dirty="0">
+                <a:solidFill>
+                  <a:srgbClr val="14213D"/>
+                </a:solidFill>
+              </a:rPr>
+              <a:t>- I filled out one of their comment cards with a minor complaint (we found the tv system cumbersome) and I actualy received an e mail ...</a:t>
+            </a:r>
+            <a:endParaRPr lang="vi-VN" sz="1050"/>
+          </a:p>
+          <a:p>
+            <a:r>
+              <a:rPr lang="vi-VN" sz="1050" dirty="0">
+                <a:solidFill>
+                  <a:srgbClr val="14213D"/>
+                </a:solidFill>
+              </a:rPr>
+              <a:t>- Each room is named after a Washington winery, and one of</a:t>
+            </a:r>
+            <a:endParaRPr lang="vi-VN" sz="1050"/>
           </a:p>
         </p:txBody>
       </p:sp>
@@ -2583,7 +2965,7 @@
                   <a:srgbClr val="2563EB"/>
                 </a:solidFill>
               </a:rPr>
-              <a:t>CAVEATS</a:t>
+              <a:t>QUALITY</a:t>
             </a:r>
             <a:endParaRPr lang="vi-VN" sz="800"/>
           </a:p>
@@ -2619,7 +3001,7 @@
                   <a:srgbClr val="14213D"/>
                 </a:solidFill>
               </a:rPr>
-              <a:t>Limitations và quyết định kỹ thuật</a:t>
+              <a:t>Metrics và health checks</a:t>
             </a:r>
             <a:endParaRPr lang="vi-VN" sz="2300"/>
           </a:p>
@@ -2655,7 +3037,7 @@
         <p:spPr>
           <a:xfrm>
             <a:off x="777240" y="1325880"/>
-            <a:ext cx="10332720" cy="2194560"/>
+            <a:ext cx="4709160" cy="2057400"/>
           </a:xfrm>
           <a:prstGeom prst="rect">
             <a:avLst/>
@@ -2679,7 +3061,7 @@
                   <a:srgbClr val="14213D"/>
                 </a:solidFill>
               </a:rPr>
-              <a:t>1. Sentiment là keyword post-processing, không phải sentiment-aware ranking.</a:t>
+              <a:t>source_fidelity: 0.6094320692641413</a:t>
             </a:r>
             <a:endParaRPr lang="vi-VN" sz="1250"/>
           </a:p>
@@ -2690,7 +3072,7 @@
                   <a:srgbClr val="14213D"/>
                 </a:solidFill>
               </a:rPr>
-              <a:t>2. Output extractive nên traceable nhưng có thể dài hoặc multi-aspect.</a:t>
+              <a:t>source_fidelity_excl_truncated: 0.96920875509799</a:t>
             </a:r>
             <a:endParaRPr lang="vi-VN" sz="1250"/>
           </a:p>
@@ -2701,7 +3083,7 @@
                   <a:srgbClr val="14213D"/>
                 </a:solidFill>
               </a:rPr>
-              <a:t>3. Tokenizer là artifact bắt buộc và phải sync cùng checkpoint.</a:t>
+              <a:t>aspect_purity: 0.5516646622593705</a:t>
             </a:r>
             <a:endParaRPr lang="vi-VN" sz="1250"/>
           </a:p>
@@ -2712,10 +3094,21 @@
                   <a:srgbClr val="14213D"/>
                 </a:solidFill>
               </a:rPr>
-              <a:t>4. Run này ưu tiên có output đúng pipeline trước deadline; xem trace/log để đánh giá độ sạch numerical.</a:t>
+              <a:t>distinct_2: 0.7179243707434944</a:t>
             </a:r>
             <a:endParaRPr lang="vi-VN" sz="1250"/>
           </a:p>
+          <a:p>
+            <a:r>
+              <a:rPr lang="vi-VN" sz="1250" dirty="0">
+                <a:solidFill>
+                  <a:srgbClr val="14213D"/>
+                </a:solidFill>
+              </a:rPr>
+              <a:t>self_bleu4: 0.01087499632043265</a:t>
+            </a:r>
+            <a:endParaRPr lang="vi-VN" sz="1250"/>
+          </a:p>
         </p:txBody>
       </p:sp>
       <p:sp>
@@ -2726,35 +3119,34 @@
         </p:nvSpPr>
         <p:spPr>
           <a:xfrm>
-            <a:off x="777240" y="4160520"/>
-            <a:ext cx="10332720" cy="594360"/>
+            <a:off x="5577840" y="1325880"/>
+            <a:ext cx="5486400" cy="1143000"/>
           </a:xfrm>
           <a:prstGeom prst="rect">
             <a:avLst/>
           </a:prstGeom>
           <a:solidFill>
-            <a:srgbClr val="ECFDF5"/>
+            <a:srgbClr val="FFFFFF"/>
           </a:solidFill>
           <a:ln w="9525">
             <a:solidFill>
-              <a:srgbClr val="99F6E4"/>
-            </a:solidFill>
-          </a:ln>
-        </p:spPr>
-        <p:txBody>
-          <a:bodyPr wrap="square" lIns="91440" tIns="45720" rIns="91440" bIns="45720"/>
-          <a:lstStyle/>
-          <a:p>
-            <a:r>
-              <a:rPr lang="vi-VN" sz="1300" dirty="0">
-                <a:b/>
-                <a:solidFill>
-                  <a:srgbClr val="14213D"/>
-                </a:solidFill>
-              </a:rPr>
-              <a:t>Final deck path: outputs/space_hasos_full_e20_pipeline_report.pptx</a:t>
-            </a:r>
-            <a:endParaRPr lang="vi-VN" sz="1300"/>
+              <a:srgbClr val="D8DEE9"/>
+            </a:solidFill>
+          </a:ln>
+        </p:spPr>
+        <p:txBody>
+          <a:bodyPr wrap="square" lIns="91440" tIns="45720" rIns="91440" bIns="45720"/>
+          <a:lstStyle/>
+          <a:p>
+            <a:r>
+              <a:rPr lang="vi-VN" sz="1250" dirty="0">
+                <a:solidFill>
+                  <a:srgbClr val="14213D"/>
+                </a:solidFill>
+              </a:rPr>
+              <a:t>HASOS không có gold summary nên dùng reference-free metrics: fidelity, purity, diversity, compression. BERTScore có thể chạy thêm nếu dependency/model tải được.</a:t>
+            </a:r>
+            <a:endParaRPr lang="vi-VN" sz="1250"/>
           </a:p>
         </p:txBody>
       </p:sp>

</xml_diff>